<commit_message>
Task 2.3: fix chart caption redundancy and card spacing/overlap in deck
- Remove redundant chart-caption text boxes now that images fill the
  full chart card (build_html_deck.py, build_presentation.py); one
  removed caption on the neighborhood slide was also stale (described
  a stacked-area chart when the slide shows YoY % change).
- Tighten slide 7 (hypotheses) and slide 8 (limitations/roadmap) card
  heights so they hug their content instead of leaving large empty
  space at the bottom.
- Fix slide 2 KPI-row vs. narrative-card overlap: increase vertical
  gap from 0.15in to 0.3in so rounded corners/shadows no longer bleed
  into each other.
- Regenerate EDA_Presentation.pptx, EDA_Presentation_slides.pdf, and
  EDA_Presentation.html from the updated build scripts.

Co-Authored-By: Claude Sonnet 5 <noreply@anthropic.com>
</commit_message>
<xml_diff>
--- a/EDA_Presentation.pptx
+++ b/EDA_Presentation.pptx
@@ -4211,8 +4211,8 @@
         </p:nvSpPr>
         <p:spPr>
           <a:xfrm>
-            <a:off x="731520" y="2560320"/>
-            <a:ext cx="4160520" cy="3611880"/>
+            <a:off x="731520" y="2743200"/>
+            <a:ext cx="4480560" cy="3429000"/>
           </a:xfrm>
           <a:prstGeom prst="roundRect">
             <a:avLst/>
@@ -4256,8 +4256,8 @@
         </p:nvSpPr>
         <p:spPr>
           <a:xfrm>
-            <a:off x="914400" y="2697480"/>
-            <a:ext cx="3794760" cy="3337560"/>
+            <a:off x="914400" y="2880360"/>
+            <a:ext cx="3794760" cy="3154680"/>
           </a:xfrm>
           <a:prstGeom prst="rect">
             <a:avLst/>
@@ -4419,45 +4419,33 @@
           </a:p>
         </p:txBody>
       </p:sp>
-      <p:sp>
-        <p:nvSpPr>
-          <p:cNvPr id="17" name="TextBox 16"/>
-          <p:cNvSpPr txBox="1"/>
-          <p:nvPr/>
-        </p:nvSpPr>
-        <p:spPr>
-          <a:xfrm>
-            <a:off x="5257800" y="5806440"/>
-            <a:ext cx="6065215" cy="274320"/>
+      <p:pic>
+        <p:nvPicPr>
+          <p:cNvPr id="16" name="Picture 15" descr="chart1_clean_hd.png"/>
+          <p:cNvPicPr>
+            <a:picLocks noChangeAspect="1"/>
+          </p:cNvPicPr>
+          <p:nvPr/>
+        </p:nvPicPr>
+        <p:blipFill>
+          <a:blip r:embed="rId2"/>
+          <a:stretch>
+            <a:fillRect/>
+          </a:stretch>
+        </p:blipFill>
+        <p:spPr>
+          <a:xfrm>
+            <a:off x="5257800" y="2432714"/>
+            <a:ext cx="6065215" cy="2632651"/>
           </a:xfrm>
           <a:prstGeom prst="rect">
             <a:avLst/>
           </a:prstGeom>
-          <a:noFill/>
-        </p:spPr>
-        <p:txBody>
-          <a:bodyPr wrap="none" lIns="0" tIns="0" rIns="0" bIns="0">
-            <a:spAutoFit/>
-          </a:bodyPr>
-          <a:lstStyle/>
-          <a:p>
-            <a:pPr>
-              <a:defRPr sz="850">
-                <a:solidFill>
-                  <a:srgbClr val="647491"/>
-                </a:solidFill>
-                <a:latin typeface="Segoe UI"/>
-              </a:defRPr>
-            </a:pPr>
-            <a:r>
-              <a:t>Chart 1 (fixed): Citywide monthly total unsheltered count with methodology regime boundaries. Unreleased 2025 months excluded, not zero-filled.</a:t>
-            </a:r>
-          </a:p>
-        </p:txBody>
-      </p:sp>
-      <p:sp>
-        <p:nvSpPr>
-          <p:cNvPr id="18" name="Rectangle 17"/>
+        </p:spPr>
+      </p:pic>
+      <p:sp>
+        <p:nvSpPr>
+          <p:cNvPr id="17" name="Rectangle 16"/>
           <p:cNvSpPr/>
           <p:nvPr/>
         </p:nvSpPr>
@@ -4500,7 +4488,7 @@
       </p:sp>
       <p:sp>
         <p:nvSpPr>
-          <p:cNvPr id="19" name="TextBox 18"/>
+          <p:cNvPr id="18" name="TextBox 17"/>
           <p:cNvSpPr txBox="1"/>
           <p:nvPr/>
         </p:nvSpPr>
@@ -4536,7 +4524,7 @@
       </p:sp>
       <p:sp>
         <p:nvSpPr>
-          <p:cNvPr id="20" name="TextBox 19"/>
+          <p:cNvPr id="19" name="TextBox 18"/>
           <p:cNvSpPr txBox="1"/>
           <p:nvPr/>
         </p:nvSpPr>
@@ -4570,30 +4558,6 @@
           </a:p>
         </p:txBody>
       </p:sp>
-      <p:pic>
-        <p:nvPicPr>
-          <p:cNvPr id="21" name="Picture 20" descr="chart1_fixed.png"/>
-          <p:cNvPicPr>
-            <a:picLocks noChangeAspect="1"/>
-          </p:cNvPicPr>
-          <p:nvPr/>
-        </p:nvPicPr>
-        <p:blipFill>
-          <a:blip r:embed="rId3"/>
-          <a:stretch>
-            <a:fillRect/>
-          </a:stretch>
-        </p:blipFill>
-        <p:spPr>
-          <a:xfrm>
-            <a:off x="5257800" y="2440305"/>
-            <a:ext cx="6062472" cy="2526030"/>
-          </a:xfrm>
-          <a:prstGeom prst="rect">
-            <a:avLst/>
-          </a:prstGeom>
-        </p:spPr>
-      </p:pic>
     </p:spTree>
   </p:cSld>
   <p:clrMapOvr>
@@ -5138,7 +5102,7 @@
       </p:sp>
       <p:pic>
         <p:nvPicPr>
-          <p:cNvPr id="10" name="Picture 9" descr="cell_30.png"/>
+          <p:cNvPr id="10" name="Picture 9" descr="chart2_clean_hd.png"/>
           <p:cNvPicPr>
             <a:picLocks noChangeAspect="1"/>
           </p:cNvPicPr>
@@ -5152,8 +5116,8 @@
         </p:blipFill>
         <p:spPr>
           <a:xfrm>
-            <a:off x="5440680" y="2122633"/>
-            <a:ext cx="5836615" cy="3024213"/>
+            <a:off x="5440680" y="2298157"/>
+            <a:ext cx="5836615" cy="2993204"/>
           </a:xfrm>
           <a:prstGeom prst="rect">
             <a:avLst/>
@@ -5162,43 +5126,7 @@
       </p:pic>
       <p:sp>
         <p:nvSpPr>
-          <p:cNvPr id="11" name="TextBox 10"/>
-          <p:cNvSpPr txBox="1"/>
-          <p:nvPr/>
-        </p:nvSpPr>
-        <p:spPr>
-          <a:xfrm>
-            <a:off x="5440680" y="5806440"/>
-            <a:ext cx="5836615" cy="274320"/>
-          </a:xfrm>
-          <a:prstGeom prst="rect">
-            <a:avLst/>
-          </a:prstGeom>
-          <a:noFill/>
-        </p:spPr>
-        <p:txBody>
-          <a:bodyPr wrap="none" lIns="0" tIns="0" rIns="0" bIns="0">
-            <a:spAutoFit/>
-          </a:bodyPr>
-          <a:lstStyle/>
-          <a:p>
-            <a:pPr>
-              <a:defRPr sz="850">
-                <a:solidFill>
-                  <a:srgbClr val="647491"/>
-                </a:solidFill>
-                <a:latin typeface="Segoe UI"/>
-              </a:defRPr>
-            </a:pPr>
-            <a:r>
-              <a:t>Chart 2 (EDA Notebook): Average monthly count by calendar month across all years with std error bars.</a:t>
-            </a:r>
-          </a:p>
-        </p:txBody>
-      </p:sp>
-      <p:sp>
-        <p:nvSpPr>
-          <p:cNvPr id="12" name="Rectangle 11"/>
+          <p:cNvPr id="11" name="Rectangle 10"/>
           <p:cNvSpPr/>
           <p:nvPr/>
         </p:nvSpPr>
@@ -5241,7 +5169,7 @@
       </p:sp>
       <p:sp>
         <p:nvSpPr>
-          <p:cNvPr id="13" name="TextBox 12"/>
+          <p:cNvPr id="12" name="TextBox 11"/>
           <p:cNvSpPr txBox="1"/>
           <p:nvPr/>
         </p:nvSpPr>
@@ -5277,7 +5205,7 @@
       </p:sp>
       <p:sp>
         <p:nvSpPr>
-          <p:cNvPr id="14" name="TextBox 13"/>
+          <p:cNvPr id="13" name="TextBox 12"/>
           <p:cNvSpPr txBox="1"/>
           <p:nvPr/>
         </p:nvSpPr>
@@ -5870,45 +5798,33 @@
           </a:p>
         </p:txBody>
       </p:sp>
-      <p:sp>
-        <p:nvSpPr>
-          <p:cNvPr id="11" name="TextBox 10"/>
-          <p:cNvSpPr txBox="1"/>
-          <p:nvPr/>
-        </p:nvSpPr>
-        <p:spPr>
-          <a:xfrm>
-            <a:off x="5440680" y="5806440"/>
-            <a:ext cx="5836615" cy="274320"/>
+      <p:pic>
+        <p:nvPicPr>
+          <p:cNvPr id="10" name="Picture 9" descr="chart7_yoy_hd.png"/>
+          <p:cNvPicPr>
+            <a:picLocks noChangeAspect="1"/>
+          </p:cNvPicPr>
+          <p:nvPr/>
+        </p:nvPicPr>
+        <p:blipFill>
+          <a:blip r:embed="rId2"/>
+          <a:stretch>
+            <a:fillRect/>
+          </a:stretch>
+        </p:blipFill>
+        <p:spPr>
+          <a:xfrm>
+            <a:off x="5440680" y="2413714"/>
+            <a:ext cx="5836615" cy="2762090"/>
           </a:xfrm>
           <a:prstGeom prst="rect">
             <a:avLst/>
           </a:prstGeom>
-          <a:noFill/>
-        </p:spPr>
-        <p:txBody>
-          <a:bodyPr wrap="none" lIns="0" tIns="0" rIns="0" bIns="0">
-            <a:spAutoFit/>
-          </a:bodyPr>
-          <a:lstStyle/>
-          <a:p>
-            <a:pPr>
-              <a:defRPr sz="850">
-                <a:solidFill>
-                  <a:srgbClr val="647491"/>
-                </a:solidFill>
-                <a:latin typeface="Segoe UI"/>
-              </a:defRPr>
-            </a:pPr>
-            <a:r>
-              <a:t>Chart (updated): Year-over-year % change by neighborhood (2018-2024) -- shows growth-rate divergence directly, matching the ranking at left.</a:t>
-            </a:r>
-          </a:p>
-        </p:txBody>
-      </p:sp>
-      <p:sp>
-        <p:nvSpPr>
-          <p:cNvPr id="12" name="Rectangle 11"/>
+        </p:spPr>
+      </p:pic>
+      <p:sp>
+        <p:nvSpPr>
+          <p:cNvPr id="11" name="Rectangle 10"/>
           <p:cNvSpPr/>
           <p:nvPr/>
         </p:nvSpPr>
@@ -5951,7 +5867,7 @@
       </p:sp>
       <p:sp>
         <p:nvSpPr>
-          <p:cNvPr id="13" name="TextBox 12"/>
+          <p:cNvPr id="12" name="TextBox 11"/>
           <p:cNvSpPr txBox="1"/>
           <p:nvPr/>
         </p:nvSpPr>
@@ -5987,7 +5903,7 @@
       </p:sp>
       <p:sp>
         <p:nvSpPr>
-          <p:cNvPr id="14" name="TextBox 13"/>
+          <p:cNvPr id="13" name="TextBox 12"/>
           <p:cNvSpPr txBox="1"/>
           <p:nvPr/>
         </p:nvSpPr>
@@ -6021,30 +5937,6 @@
           </a:p>
         </p:txBody>
       </p:sp>
-      <p:pic>
-        <p:nvPicPr>
-          <p:cNvPr id="15" name="Picture 14" descr="chart_yoy_by_neighborhood.png"/>
-          <p:cNvPicPr>
-            <a:picLocks noChangeAspect="1"/>
-          </p:cNvPicPr>
-          <p:nvPr/>
-        </p:nvPicPr>
-        <p:blipFill>
-          <a:blip r:embed="rId3"/>
-          <a:stretch>
-            <a:fillRect/>
-          </a:stretch>
-        </p:blipFill>
-        <p:spPr>
-          <a:xfrm>
-            <a:off x="5440680" y="2374859"/>
-            <a:ext cx="5833872" cy="2656921"/>
-          </a:xfrm>
-          <a:prstGeom prst="rect">
-            <a:avLst/>
-          </a:prstGeom>
-        </p:spPr>
-      </p:pic>
     </p:spTree>
   </p:cSld>
   <p:clrMapOvr>
@@ -6560,7 +6452,7 @@
       </p:sp>
       <p:pic>
         <p:nvPicPr>
-          <p:cNvPr id="10" name="Picture 9" descr="cell_48.png"/>
+          <p:cNvPr id="10" name="Picture 9" descr="chart8_clean_hd.png"/>
           <p:cNvPicPr>
             <a:picLocks noChangeAspect="1"/>
           </p:cNvPicPr>
@@ -6574,8 +6466,8 @@
         </p:blipFill>
         <p:spPr>
           <a:xfrm>
-            <a:off x="5440680" y="2244483"/>
-            <a:ext cx="5836615" cy="2780512"/>
+            <a:off x="5440680" y="2417456"/>
+            <a:ext cx="5836615" cy="2754606"/>
           </a:xfrm>
           <a:prstGeom prst="rect">
             <a:avLst/>
@@ -6584,43 +6476,7 @@
       </p:pic>
       <p:sp>
         <p:nvSpPr>
-          <p:cNvPr id="11" name="TextBox 10"/>
-          <p:cNvSpPr txBox="1"/>
-          <p:nvPr/>
-        </p:nvSpPr>
-        <p:spPr>
-          <a:xfrm>
-            <a:off x="5440680" y="5806440"/>
-            <a:ext cx="5836615" cy="274320"/>
-          </a:xfrm>
-          <a:prstGeom prst="rect">
-            <a:avLst/>
-          </a:prstGeom>
-          <a:noFill/>
-        </p:spPr>
-        <p:txBody>
-          <a:bodyPr wrap="none" lIns="0" tIns="0" rIns="0" bIns="0">
-            <a:spAutoFit/>
-          </a:bodyPr>
-          <a:lstStyle/>
-          <a:p>
-            <a:pPr>
-              <a:defRPr sz="850">
-                <a:solidFill>
-                  <a:srgbClr val="647491"/>
-                </a:solidFill>
-                <a:latin typeface="Segoe UI"/>
-              </a:defRPr>
-            </a:pPr>
-            <a:r>
-              <a:t>Chart 8 (EDA Notebook): Overall monthly count trajectory (2019–2022) with shaded COVID-19 period.</a:t>
-            </a:r>
-          </a:p>
-        </p:txBody>
-      </p:sp>
-      <p:sp>
-        <p:nvSpPr>
-          <p:cNvPr id="12" name="Rectangle 11"/>
+          <p:cNvPr id="11" name="Rectangle 10"/>
           <p:cNvSpPr/>
           <p:nvPr/>
         </p:nvSpPr>
@@ -6663,7 +6519,7 @@
       </p:sp>
       <p:sp>
         <p:nvSpPr>
-          <p:cNvPr id="13" name="TextBox 12"/>
+          <p:cNvPr id="12" name="TextBox 11"/>
           <p:cNvSpPr txBox="1"/>
           <p:nvPr/>
         </p:nvSpPr>
@@ -6699,7 +6555,7 @@
       </p:sp>
       <p:sp>
         <p:nvSpPr>
-          <p:cNvPr id="14" name="TextBox 13"/>
+          <p:cNvPr id="13" name="TextBox 12"/>
           <p:cNvSpPr txBox="1"/>
           <p:nvPr/>
         </p:nvSpPr>
@@ -7282,45 +7138,33 @@
           </a:p>
         </p:txBody>
       </p:sp>
-      <p:sp>
-        <p:nvSpPr>
-          <p:cNvPr id="11" name="TextBox 10"/>
-          <p:cNvSpPr txBox="1"/>
-          <p:nvPr/>
-        </p:nvSpPr>
-        <p:spPr>
-          <a:xfrm>
-            <a:off x="5440680" y="5806440"/>
-            <a:ext cx="5836615" cy="274320"/>
+      <p:pic>
+        <p:nvPicPr>
+          <p:cNvPr id="10" name="Picture 9" descr="chart9_clean_hd.png"/>
+          <p:cNvPicPr>
+            <a:picLocks noChangeAspect="1"/>
+          </p:cNvPicPr>
+          <p:nvPr/>
+        </p:nvPicPr>
+        <p:blipFill>
+          <a:blip r:embed="rId2"/>
+          <a:stretch>
+            <a:fillRect/>
+          </a:stretch>
+        </p:blipFill>
+        <p:spPr>
+          <a:xfrm>
+            <a:off x="5440680" y="2528047"/>
+            <a:ext cx="5836615" cy="2533425"/>
           </a:xfrm>
           <a:prstGeom prst="rect">
             <a:avLst/>
           </a:prstGeom>
-          <a:noFill/>
-        </p:spPr>
-        <p:txBody>
-          <a:bodyPr wrap="none" lIns="0" tIns="0" rIns="0" bIns="0">
-            <a:spAutoFit/>
-          </a:bodyPr>
-          <a:lstStyle/>
-          <a:p>
-            <a:pPr>
-              <a:defRPr sz="850">
-                <a:solidFill>
-                  <a:srgbClr val="647491"/>
-                </a:solidFill>
-                <a:latin typeface="Segoe UI"/>
-              </a:defRPr>
-            </a:pPr>
-            <a:r>
-              <a:t>Chart 9 (fixed): Monthly adjustment gap (Adjusted Total - Raw Observed Count). Unreleased 2025 months excluded, not zero-filled.</a:t>
-            </a:r>
-          </a:p>
-        </p:txBody>
-      </p:sp>
-      <p:sp>
-        <p:nvSpPr>
-          <p:cNvPr id="12" name="Rectangle 11"/>
+        </p:spPr>
+      </p:pic>
+      <p:sp>
+        <p:nvSpPr>
+          <p:cNvPr id="11" name="Rectangle 10"/>
           <p:cNvSpPr/>
           <p:nvPr/>
         </p:nvSpPr>
@@ -7363,7 +7207,7 @@
       </p:sp>
       <p:sp>
         <p:nvSpPr>
-          <p:cNvPr id="13" name="TextBox 12"/>
+          <p:cNvPr id="12" name="TextBox 11"/>
           <p:cNvSpPr txBox="1"/>
           <p:nvPr/>
         </p:nvSpPr>
@@ -7399,7 +7243,7 @@
       </p:sp>
       <p:sp>
         <p:nvSpPr>
-          <p:cNvPr id="14" name="TextBox 13"/>
+          <p:cNvPr id="13" name="TextBox 12"/>
           <p:cNvSpPr txBox="1"/>
           <p:nvPr/>
         </p:nvSpPr>
@@ -7433,30 +7277,6 @@
           </a:p>
         </p:txBody>
       </p:sp>
-      <p:pic>
-        <p:nvPicPr>
-          <p:cNvPr id="15" name="Picture 14" descr="chart9_fixed.png"/>
-          <p:cNvPicPr>
-            <a:picLocks noChangeAspect="1"/>
-          </p:cNvPicPr>
-          <p:nvPr/>
-        </p:nvPicPr>
-        <p:blipFill>
-          <a:blip r:embed="rId3"/>
-          <a:stretch>
-            <a:fillRect/>
-          </a:stretch>
-        </p:blipFill>
-        <p:spPr>
-          <a:xfrm>
-            <a:off x="5440680" y="2488403"/>
-            <a:ext cx="5833872" cy="2429833"/>
-          </a:xfrm>
-          <a:prstGeom prst="rect">
-            <a:avLst/>
-          </a:prstGeom>
-        </p:spPr>
-      </p:pic>
     </p:spTree>
   </p:cSld>
   <p:clrMapOvr>
@@ -7717,8 +7537,8 @@
         </p:nvSpPr>
         <p:spPr>
           <a:xfrm>
-            <a:off x="731520" y="1371600"/>
-            <a:ext cx="5287975" cy="2286000"/>
+            <a:off x="731520" y="1417320"/>
+            <a:ext cx="5287975" cy="1874519"/>
           </a:xfrm>
           <a:prstGeom prst="roundRect">
             <a:avLst/>
@@ -7762,7 +7582,7 @@
         </p:nvSpPr>
         <p:spPr>
           <a:xfrm>
-            <a:off x="749808" y="1389888"/>
+            <a:off x="749808" y="1435608"/>
             <a:ext cx="5251399" cy="54864"/>
           </a:xfrm>
           <a:prstGeom prst="rect">
@@ -7805,8 +7625,8 @@
         </p:nvSpPr>
         <p:spPr>
           <a:xfrm>
-            <a:off x="914400" y="1536192"/>
-            <a:ext cx="4922215" cy="2011680"/>
+            <a:off x="914400" y="1581912"/>
+            <a:ext cx="4922215" cy="1600199"/>
           </a:xfrm>
           <a:prstGeom prst="rect">
             <a:avLst/>
@@ -7889,8 +7709,8 @@
         </p:nvSpPr>
         <p:spPr>
           <a:xfrm>
-            <a:off x="6172200" y="1371600"/>
-            <a:ext cx="5287975" cy="2286000"/>
+            <a:off x="6172200" y="1417320"/>
+            <a:ext cx="5287975" cy="1874519"/>
           </a:xfrm>
           <a:prstGeom prst="roundRect">
             <a:avLst/>
@@ -7934,7 +7754,7 @@
         </p:nvSpPr>
         <p:spPr>
           <a:xfrm>
-            <a:off x="6190488" y="1389888"/>
+            <a:off x="6190488" y="1435608"/>
             <a:ext cx="5251399" cy="54864"/>
           </a:xfrm>
           <a:prstGeom prst="rect">
@@ -7977,8 +7797,8 @@
         </p:nvSpPr>
         <p:spPr>
           <a:xfrm>
-            <a:off x="6355080" y="1536192"/>
-            <a:ext cx="4922215" cy="2011680"/>
+            <a:off x="6355080" y="1581912"/>
+            <a:ext cx="4922215" cy="1600199"/>
           </a:xfrm>
           <a:prstGeom prst="rect">
             <a:avLst/>
@@ -8061,8 +7881,8 @@
         </p:nvSpPr>
         <p:spPr>
           <a:xfrm>
-            <a:off x="731520" y="3794760"/>
-            <a:ext cx="5287975" cy="2286000"/>
+            <a:off x="731520" y="3566160"/>
+            <a:ext cx="5287975" cy="1874519"/>
           </a:xfrm>
           <a:prstGeom prst="roundRect">
             <a:avLst/>
@@ -8106,7 +7926,7 @@
         </p:nvSpPr>
         <p:spPr>
           <a:xfrm>
-            <a:off x="749808" y="3813048"/>
+            <a:off x="749808" y="3584448"/>
             <a:ext cx="5251399" cy="54864"/>
           </a:xfrm>
           <a:prstGeom prst="rect">
@@ -8149,8 +7969,8 @@
         </p:nvSpPr>
         <p:spPr>
           <a:xfrm>
-            <a:off x="914400" y="3959352"/>
-            <a:ext cx="4922215" cy="2011680"/>
+            <a:off x="914400" y="3730752"/>
+            <a:ext cx="4922215" cy="1600199"/>
           </a:xfrm>
           <a:prstGeom prst="rect">
             <a:avLst/>
@@ -8233,8 +8053,8 @@
         </p:nvSpPr>
         <p:spPr>
           <a:xfrm>
-            <a:off x="6172200" y="3794760"/>
-            <a:ext cx="5287975" cy="2286000"/>
+            <a:off x="6172200" y="3566160"/>
+            <a:ext cx="5287975" cy="1874519"/>
           </a:xfrm>
           <a:prstGeom prst="roundRect">
             <a:avLst/>
@@ -8278,7 +8098,7 @@
         </p:nvSpPr>
         <p:spPr>
           <a:xfrm>
-            <a:off x="6190488" y="3813048"/>
+            <a:off x="6190488" y="3584448"/>
             <a:ext cx="5251399" cy="54864"/>
           </a:xfrm>
           <a:prstGeom prst="rect">
@@ -8321,8 +8141,8 @@
         </p:nvSpPr>
         <p:spPr>
           <a:xfrm>
-            <a:off x="6355080" y="3959352"/>
-            <a:ext cx="4922215" cy="2011680"/>
+            <a:off x="6355080" y="3730752"/>
+            <a:ext cx="4922215" cy="1600199"/>
           </a:xfrm>
           <a:prstGeom prst="rect">
             <a:avLst/>
@@ -8772,8 +8592,8 @@
         </p:nvSpPr>
         <p:spPr>
           <a:xfrm>
-            <a:off x="731520" y="1371600"/>
-            <a:ext cx="5257800" cy="4800600"/>
+            <a:off x="731520" y="2194560"/>
+            <a:ext cx="5257800" cy="3246120"/>
           </a:xfrm>
           <a:prstGeom prst="roundRect">
             <a:avLst/>
@@ -8817,8 +8637,8 @@
         </p:nvSpPr>
         <p:spPr>
           <a:xfrm>
-            <a:off x="960120" y="1554480"/>
-            <a:ext cx="4800600" cy="4434840"/>
+            <a:off x="960120" y="2377440"/>
+            <a:ext cx="4800600" cy="2880360"/>
           </a:xfrm>
           <a:prstGeom prst="rect">
             <a:avLst/>
@@ -8972,8 +8792,8 @@
         </p:nvSpPr>
         <p:spPr>
           <a:xfrm>
-            <a:off x="6202375" y="1371600"/>
-            <a:ext cx="5257800" cy="4800600"/>
+            <a:off x="6202375" y="2194560"/>
+            <a:ext cx="5257800" cy="3246120"/>
           </a:xfrm>
           <a:prstGeom prst="roundRect">
             <a:avLst/>
@@ -9017,8 +8837,8 @@
         </p:nvSpPr>
         <p:spPr>
           <a:xfrm>
-            <a:off x="6430975" y="1554480"/>
-            <a:ext cx="4800600" cy="4434840"/>
+            <a:off x="6430975" y="2377440"/>
+            <a:ext cx="4800600" cy="2880360"/>
           </a:xfrm>
           <a:prstGeom prst="rect">
             <a:avLst/>

</xml_diff>

<commit_message>
fix(audit): apply source corrections, cascade re-runs, and deliverable documentation suite
- Audited and corrected raw count discrepancies via data/source_corrections.csv and scripts/apply_source_corrections.py
- Rebuilt MasterCounts_Adjusted_v2.csv across all 574 component area-months (eliminated Feb 2018 City Center error; std dev dropped from 8.00 to 1.67)
- Executed full cascade re-runs for EDA, decomposition, stationarity, structural breaks, forecasting, and macro county estimation
- Updated and synchronized all technical reports and non-technical executive summary in docs/
- Generated missing deliverables: StrategicRecommendations_Memo.md, Dashboard_MaintenanceGuide.md, FutureEnhancement_Roadmap.md
- Aligned dashboard hotspot significance tiers and digitized count dates
- Passed 100% of unit test suites (46/46 pytest) and all validation harnesses
</commit_message>
<xml_diff>
--- a/EDA_Presentation.pptx
+++ b/EDA_Presentation.pptx
@@ -4172,7 +4172,7 @@
               </a:defRPr>
             </a:pPr>
             <a:r>
-              <a:t>156.8</a:t>
+              <a:t>156.4</a:t>
             </a:r>
           </a:p>
           <a:p>
@@ -4311,7 +4311,7 @@
               </a:defRPr>
             </a:pPr>
             <a:r>
-              <a:t>  Annual average fell from 176.31 to 109.02 (~-38% cumulative drop). Year-over-year changes: -18.98% (2018), -4.94% (2019), and -19.71% (2020).</a:t>
+              <a:t>  Annual average fell from 176.31 to 109.02 (~-38% cumulative drop). Year-over-year changes: -20.31% (2018), -3.87% (2019), and -19.29% (2020).</a:t>
             </a:r>
           </a:p>
           <a:p>
@@ -4340,7 +4340,7 @@
               </a:defRPr>
             </a:pPr>
             <a:r>
-              <a:t>  Counts rebounded sharply: +25.85% (2021) and +57.63% (2022), reaching an annual average of 223.98 in 2023 — more than double the 2020 trough.</a:t>
+              <a:t>  Counts rebounded sharply: +25.85% (2021) and +57.55% (2022), reaching an annual average of 223.30 in 2023 — more than double the 2020 trough.</a:t>
             </a:r>
           </a:p>
           <a:p>
@@ -4369,7 +4369,7 @@
               </a:defRPr>
             </a:pPr>
             <a:r>
-              <a:t>  A steep -43.52% drop in 2024 brought the annual average down to 126.50; 2025 remained roughly flat (-2.94%) at 122.78.</a:t>
+              <a:t>  A steep -43.26% drop in 2024 brought the annual average down to 126.71; 2025 remained roughly flat (-2.56%) at 123.47.</a:t>
             </a:r>
           </a:p>
         </p:txBody>
@@ -4435,8 +4435,8 @@
         </p:blipFill>
         <p:spPr>
           <a:xfrm>
-            <a:off x="5257800" y="2432714"/>
-            <a:ext cx="6065215" cy="2632651"/>
+            <a:off x="5257800" y="2419774"/>
+            <a:ext cx="6065215" cy="2658531"/>
           </a:xfrm>
           <a:prstGeom prst="rect">
             <a:avLst/>
@@ -4934,7 +4934,7 @@
               </a:defRPr>
             </a:pPr>
             <a:r>
-              <a:t>  No single calendar month deviates by more than ~5% from the grand mean (156.78). The peak-to-trough spread is only ~8.4 percentage points.</a:t>
+              <a:t>  No single calendar month deviates by more than ~5% from the grand mean (156.44). The peak-to-trough spread is only ~8.1 percentage points.</a:t>
             </a:r>
           </a:p>
           <a:p>
@@ -5116,8 +5116,8 @@
         </p:blipFill>
         <p:spPr>
           <a:xfrm>
-            <a:off x="5440680" y="2298157"/>
-            <a:ext cx="5836615" cy="2993204"/>
+            <a:off x="5440680" y="2282653"/>
+            <a:ext cx="5836615" cy="3024213"/>
           </a:xfrm>
           <a:prstGeom prst="rect">
             <a:avLst/>
@@ -5612,7 +5612,7 @@
               </a:defRPr>
             </a:pPr>
             <a:r>
-              <a:t>    1. East Village: 552.77 (std 157.09 — highest volume &amp; volatility)</a:t>
+              <a:t>    1. East Village: 552.04 (std 157.27 — highest volume &amp; volatility)</a:t>
             </a:r>
           </a:p>
           <a:p>
@@ -5638,7 +5638,7 @@
               </a:defRPr>
             </a:pPr>
             <a:r>
-              <a:t>    3. City Center: 171.81 (std 54.80)</a:t>
+              <a:t>    3. City Center: 170.68 (std 52.95)</a:t>
             </a:r>
           </a:p>
           <a:p>
@@ -5651,7 +5651,7 @@
               </a:defRPr>
             </a:pPr>
             <a:r>
-              <a:t>    4. Cortez: 59.52  |  5. Gaslamp: 48.43</a:t>
+              <a:t>    4. Cortez: 59.62  |  5. Gaslamp: 48.17</a:t>
             </a:r>
           </a:p>
           <a:p>
@@ -5664,7 +5664,7 @@
               </a:defRPr>
             </a:pPr>
             <a:r>
-              <a:t>    6. Columbia: 44.49  |  7. Marina: 30.94 (smallest, std 15.82)</a:t>
+              <a:t>    6. Columbia: 44.49  |  7. Marina: 30.75 (smallest, std 15.54)</a:t>
             </a:r>
           </a:p>
           <a:p>
@@ -5693,7 +5693,7 @@
               </a:defRPr>
             </a:pPr>
             <a:r>
-              <a:t>  - Fastest Growing: Outside Perimeter (+26.90%/yr), Cortez (+11.96%/yr), City Center (+3.94%/yr).</a:t>
+              <a:t>  - Fastest Growing: Outside Perimeter (+26.90%/yr), Cortez (+12.12%/yr), City Center (+5.19%/yr).</a:t>
             </a:r>
           </a:p>
           <a:p>
@@ -5719,7 +5719,7 @@
               </a:defRPr>
             </a:pPr>
             <a:r>
-              <a:t>  - Shrinking Areas: Marina (-12.76%/yr) and Columbia (-4.28%/yr) had sustained drops.</a:t>
+              <a:t>  - Shrinking Areas: Marina (-13.11%/yr) and Columbia (-4.28%/yr) had sustained drops.</a:t>
             </a:r>
           </a:p>
           <a:p>
@@ -5814,8 +5814,8 @@
         </p:blipFill>
         <p:spPr>
           <a:xfrm>
-            <a:off x="5440680" y="2413714"/>
-            <a:ext cx="5836615" cy="2762090"/>
+            <a:off x="5440680" y="2400130"/>
+            <a:ext cx="5836615" cy="2789258"/>
           </a:xfrm>
           <a:prstGeom prst="rect">
             <a:avLst/>
@@ -6342,7 +6342,7 @@
               </a:defRPr>
             </a:pPr>
             <a:r>
-              <a:t>  2020 annual average (654.1) dropped ~20% below the 2019 pre-COVID baseline (814.72), reflecting -19.71% YoY contraction.</a:t>
+              <a:t>  2020 annual average (654.1) dropped ~20% below the 2019 pre-COVID baseline (810.43), reflecting -19.29% YoY contraction.</a:t>
             </a:r>
           </a:p>
           <a:p>
@@ -6466,8 +6466,8 @@
         </p:blipFill>
         <p:spPr>
           <a:xfrm>
-            <a:off x="5440680" y="2417456"/>
-            <a:ext cx="5836615" cy="2754606"/>
+            <a:off x="5440680" y="2405675"/>
+            <a:ext cx="5836615" cy="2778169"/>
           </a:xfrm>
           <a:prstGeom prst="rect">
             <a:avLst/>
@@ -6936,7 +6936,7 @@
               </a:defRPr>
             </a:pPr>
             <a:r>
-              <a:t>Conclusion: Multipliers produce a proportional gap without distorting longitudinal trendlines.</a:t>
+              <a:t>Conclusion: Multipliers add only a small gap (within ±2/month on average) and do not distort longitudinal trends.</a:t>
             </a:r>
           </a:p>
           <a:p>
@@ -7017,7 +7017,7 @@
               </a:defRPr>
             </a:pPr>
             <a:r>
-              <a:t>• 2018 Volatility &amp; Source Discrepancy:</a:t>
+              <a:t>• Gap Is Small in Every Year:</a:t>
             </a:r>
           </a:p>
           <a:p>
@@ -7030,7 +7030,7 @@
               </a:defRPr>
             </a:pPr>
             <a:r>
-              <a:t>  Gap (total_count - raw_count) peaked in 2018 (avg +13.5/mo, spiking to +156.61 in Feb 2018). Audit logged Feb 2018 spike as partly a source-PDF addition error (+30 discrepancy), not purely multiplier mechanics.</a:t>
+              <a:t>  Gap (total_count - raw_count) averages within ±2/month each year: DSDP published totals already include the multipliers. The earlier Feb 2018 spike (+156.61) was a data-entry error (100 tents instead of 10), corrected against the source map in Oct 2026.</a:t>
             </a:r>
           </a:p>
           <a:p>
@@ -7046,7 +7046,7 @@
               </a:defRPr>
             </a:pPr>
             <a:r>
-              <a:t>• 2019+ Gap Stabilization:</a:t>
+              <a:t>• Remaining Outliers Are Source Conflicts:</a:t>
             </a:r>
           </a:p>
           <a:p>
@@ -7059,7 +7059,7 @@
               </a:defRPr>
             </a:pPr>
             <a:r>
-              <a:t>  From 2019 onward, monthly gap stabilized to near-zero (roughly ±1 to ±5/month), well within expected rounding tolerance (±2).</a:t>
+              <a:t>  The largest remaining single-month gaps (Apr 2020 +19.7, Feb 2023 -12.5) are months where DSDP map pages and its summary table disagree; listed in MasterCounts_QA_Flags.csv.</a:t>
             </a:r>
           </a:p>
           <a:p>
@@ -7154,8 +7154,8 @@
         </p:blipFill>
         <p:spPr>
           <a:xfrm>
-            <a:off x="5440680" y="2528047"/>
-            <a:ext cx="5836615" cy="2533425"/>
+            <a:off x="5440680" y="2515594"/>
+            <a:ext cx="5836615" cy="2558330"/>
           </a:xfrm>
           <a:prstGeom prst="rect">
             <a:avLst/>
@@ -7683,7 +7683,7 @@
               </a:defRPr>
             </a:pPr>
             <a:r>
-              <a:t>The +57.63% (2022) surge hit nearly every neighborhood simultaneously (Cortez +129%, Outside Perimeter +87%, East Village +50%). This synchronized timing points to systemic citywide drivers (eviction moratorium expirations, shelter demobilizations, or sweep shifts) rather than local dynamics.</a:t>
+              <a:t>The +57.55% (2022) surge hit nearly every neighborhood simultaneously (Cortez +132%, Outside Perimeter +87%, East Village +50%). This synchronized timing points to systemic citywide drivers (eviction moratorium expirations, shelter demobilizations, or sweep shifts) rather than local dynamics.</a:t>
             </a:r>
           </a:p>
           <a:p>
@@ -7995,7 +7995,7 @@
               </a:defRPr>
             </a:pPr>
             <a:r>
-              <a:t>H3: 2024 Pullback (-43.52%) May Be a Reporting Artifact</a:t>
+              <a:t>H3: 2024 Pullback (-43.26%) May Be a Reporting Artifact</a:t>
             </a:r>
           </a:p>
           <a:p>
@@ -8027,7 +8027,7 @@
               </a:defRPr>
             </a:pPr>
             <a:r>
-              <a:t>A steep -43.52% drop in a single year immediately after the historical peak warrants verification against external benchmarks before reading it as a true population drop. Count area or staffing changes may be confounders.</a:t>
+              <a:t>A steep -43.26% drop in a single year immediately after the historical peak warrants verification against external benchmarks before reading it as a true population drop. Count area or staffing changes may be confounders.</a:t>
             </a:r>
           </a:p>
           <a:p>
@@ -8199,7 +8199,7 @@
               </a:defRPr>
             </a:pPr>
             <a:r>
-              <a:t>Mid-sized areas grow fastest (Outside Perimeter +26.90%, Cortez +11.96%, City Center +3.94%), while East Village grows slowly (+1.64%) and Marina shrinks (-12.76%). Enforcement in core areas may displace individuals to borders.</a:t>
+              <a:t>Mid-sized areas grow fastest (Outside Perimeter +26.90%, Cortez +12.12%, City Center +5.19%), while East Village grows slowly (+1.75%) and Marina shrinks (-13.11%). Enforcement in core areas may displace individuals to borders.</a:t>
             </a:r>
           </a:p>
           <a:p>

</xml_diff>